<commit_message>
decksmith 1.0.1: plugin install, demo points at the repo
SKILL.md explains where the scripts live once installed as a plugin and that
the repo, not the plugin cache, is the source to edit. Demo slide 7 now shows
github.com/JahooClou/decksmith; the example deck and README images are
re-rendered from the rebuilt demo.

Co-Authored-By: Claude Opus 5.5 <noreply@anthropic.com>
</commit_message>
<xml_diff>
--- a/examples/demo/decksmith-demo.pptx
+++ b/examples/demo/decksmith-demo.pptx
@@ -113,24 +113,24 @@
   <p:extLst>
     <p:ext uri="{521415D9-36F7-43E2-AB2F-B90AF26B5E84}">
       <p14:sectionLst xmlns:p14="http://schemas.microsoft.com/office/powerpoint/2010/main">
-        <p14:section name="Opening" id="{30C9BC36-714B-4EF9-AFF7-0956426BF242}">
+        <p14:section name="Opening" id="{B7670967-5D07-455D-A3D3-8F2B4DBEE62B}">
           <p14:sldIdLst>
             <p14:sldId id="256"/>
           </p14:sldIdLst>
         </p14:section>
-        <p14:section name="Motion" id="{5BCD33C7-B7AC-4E9A-A7B6-2343AE40426D}">
+        <p14:section name="Motion" id="{D6146837-0AF5-4B09-A201-D9867CE3C65E}">
           <p14:sldIdLst>
             <p14:sldId id="257"/>
             <p14:sldId id="258"/>
             <p14:sldId id="259"/>
           </p14:sldIdLst>
         </p14:section>
-        <p14:section name="Navigation" id="{4AC4C13C-EA2C-4FBD-9642-3CB0A8728A28}">
+        <p14:section name="Navigation" id="{B232E54F-8572-43B1-B46B-3E79E18A08A2}">
           <p14:sldIdLst>
             <p14:sldId id="260"/>
           </p14:sldIdLst>
         </p14:section>
-        <p14:section name="Limits" id="{2290F2C3-2200-4509-86CF-EB4102153E2D}">
+        <p14:section name="Limits" id="{21BE88FD-0D5E-46FD-A0DB-4CB66252523B}">
           <p14:sldIdLst>
             <p14:sldId id="261"/>
             <p14:sldId id="262"/>
@@ -1284,7 +1284,7 @@
           </a:p>
           <a:p>
             <a:r>
-              <a:t>The button jumps back to slide 1 in the show. The skill lives at the path on screen.</a:t>
+              <a:t>The button jumps back to slide 1 in the show. The skill is on GitHub at the address on screen.</a:t>
             </a:r>
           </a:p>
         </p:txBody>
@@ -4830,7 +4830,7 @@
               <a:graphicData uri="http://schemas.microsoft.com/office/powerpoint/2016/slidezoom">
                 <pslz:sldZm>
                   <pslz:sldZmObj sldId="257">
-                    <pslz:zmPr xmlns:p166="http://schemas.microsoft.com/office/powerpoint/2016/6/main" id="{18495502-7699-4339-BF84-DC564804CBDA}" returnToParent="1" transitionDur="1000">
+                    <pslz:zmPr xmlns:p166="http://schemas.microsoft.com/office/powerpoint/2016/6/main" id="{FB7FC726-BEF8-4F59-A404-B873C708874A}" returnToParent="1" transitionDur="1000">
                       <p166:blipFill>
                         <a:blip r:embed="rId2"/>
                         <a:stretch>
@@ -5727,7 +5727,7 @@
                 </a:solidFill>
                 <a:latin typeface="IBM Plex Mono"/>
               </a:rPr>
-              <a:t>Z:\Claude\.claude\skills\decksmith</a:t>
+              <a:t>github.com/JahooClou/decksmith</a:t>
             </a:r>
           </a:p>
         </p:txBody>

</xml_diff>